<commit_message>
Fix Snowflake board brief SQL and refresh Lab deck materials.
Replace share_expansion correlated subquery with a JOIN so Interview Lab board works on Snowflake; make board brief resilient per metric; regenerate PDF/PPTX with Lab/Market/voice coverage.

Co-authored-by: Cursor <cursoragent@cursor.com>
</commit_message>
<xml_diff>
--- a/docs/deck/VC_Retail_Analytics_Interview.pptx
+++ b/docs/deck/VC_Retail_Analytics_Interview.pptx
@@ -22,6 +22,7 @@
     <p:sldId id="270" r:id="rId21"/>
     <p:sldId id="271" r:id="rId22"/>
     <p:sldId id="272" r:id="rId23"/>
+    <p:sldId id="273" r:id="rId24"/>
   </p:sldIdLst>
   <p:sldSz cx="12191695" cy="6858000" type="screen4x3"/>
   <p:notesSz cx="6858000" cy="9144000"/>
@@ -3969,7 +3970,7 @@
                 </a:solidFill>
                 <a:latin typeface="Calibri"/>
               </a:rPr>
-              <a:t>10/17</a:t>
+              <a:t>10/18</a:t>
             </a:r>
           </a:p>
         </p:txBody>
@@ -4292,7 +4293,7 @@
                 </a:solidFill>
                 <a:latin typeface="Calibri"/>
               </a:rPr>
-              <a:t>11/17</a:t>
+              <a:t>11/18</a:t>
             </a:r>
           </a:p>
         </p:txBody>
@@ -5396,7 +5397,7 @@
                 </a:solidFill>
                 <a:latin typeface="Calibri"/>
               </a:rPr>
-              <a:t>12/17</a:t>
+              <a:t>12/18</a:t>
             </a:r>
           </a:p>
         </p:txBody>
@@ -5719,7 +5720,7 @@
                 </a:solidFill>
                 <a:latin typeface="Calibri"/>
               </a:rPr>
-              <a:t>13/17</a:t>
+              <a:t>13/18</a:t>
             </a:r>
           </a:p>
         </p:txBody>
@@ -6042,7 +6043,7 @@
                 </a:solidFill>
                 <a:latin typeface="Calibri"/>
               </a:rPr>
-              <a:t>14/17</a:t>
+              <a:t>14/18</a:t>
             </a:r>
           </a:p>
         </p:txBody>
@@ -6389,7 +6390,7 @@
                 </a:solidFill>
                 <a:latin typeface="Calibri"/>
               </a:rPr>
-              <a:t>15/17</a:t>
+              <a:t>15/18</a:t>
             </a:r>
           </a:p>
         </p:txBody>
@@ -7059,7 +7060,7 @@
                 </a:solidFill>
                 <a:latin typeface="Calibri"/>
               </a:rPr>
-              <a:t>16/17</a:t>
+              <a:t>16/18</a:t>
             </a:r>
           </a:p>
         </p:txBody>
@@ -7097,6 +7098,1253 @@
             <a:avLst/>
           </a:prstGeom>
           <a:solidFill>
+            <a:srgbClr val="F3EFE6"/>
+          </a:solidFill>
+          <a:ln>
+            <a:noFill/>
+          </a:ln>
+        </p:spPr>
+        <p:style>
+          <a:lnRef idx="1">
+            <a:schemeClr val="accent1"/>
+          </a:lnRef>
+          <a:fillRef idx="3">
+            <a:schemeClr val="accent1"/>
+          </a:fillRef>
+          <a:effectRef idx="2">
+            <a:schemeClr val="accent1"/>
+          </a:effectRef>
+          <a:fontRef idx="minor">
+            <a:schemeClr val="lt1"/>
+          </a:fontRef>
+        </p:style>
+        <p:txBody>
+          <a:bodyPr rtlCol="0" anchor="ctr"/>
+          <a:lstStyle/>
+          <a:p>
+            <a:pPr algn="ctr"/>
+          </a:p>
+        </p:txBody>
+      </p:sp>
+      <p:sp>
+        <p:nvSpPr>
+          <p:cNvPr id="3" name="TextBox 2"/>
+          <p:cNvSpPr txBox="1"/>
+          <p:nvPr/>
+        </p:nvSpPr>
+        <p:spPr>
+          <a:xfrm>
+            <a:off x="594360" y="292608"/>
+            <a:ext cx="10058400" cy="256032"/>
+          </a:xfrm>
+          <a:prstGeom prst="rect">
+            <a:avLst/>
+          </a:prstGeom>
+          <a:noFill/>
+        </p:spPr>
+        <p:txBody>
+          <a:bodyPr wrap="square">
+            <a:spAutoFit/>
+          </a:bodyPr>
+          <a:lstStyle/>
+          <a:p>
+            <a:pPr algn="l"/>
+            <a:r>
+              <a:rPr sz="1100" b="1" u="none">
+                <a:solidFill>
+                  <a:srgbClr val="8A6A3B"/>
+                </a:solidFill>
+                <a:latin typeface="Calibri"/>
+              </a:rPr>
+              <a:t>INTERVIEW LAB</a:t>
+            </a:r>
+          </a:p>
+        </p:txBody>
+      </p:sp>
+      <p:sp>
+        <p:nvSpPr>
+          <p:cNvPr id="4" name="Rectangle 3"/>
+          <p:cNvSpPr/>
+          <p:nvPr/>
+        </p:nvSpPr>
+        <p:spPr>
+          <a:xfrm>
+            <a:off x="594360" y="658368"/>
+            <a:ext cx="73152" cy="438912"/>
+          </a:xfrm>
+          <a:prstGeom prst="rect">
+            <a:avLst/>
+          </a:prstGeom>
+          <a:solidFill>
+            <a:srgbClr val="8A6A3B"/>
+          </a:solidFill>
+          <a:ln>
+            <a:noFill/>
+          </a:ln>
+        </p:spPr>
+        <p:style>
+          <a:lnRef idx="1">
+            <a:schemeClr val="accent1"/>
+          </a:lnRef>
+          <a:fillRef idx="3">
+            <a:schemeClr val="accent1"/>
+          </a:fillRef>
+          <a:effectRef idx="2">
+            <a:schemeClr val="accent1"/>
+          </a:effectRef>
+          <a:fontRef idx="minor">
+            <a:schemeClr val="lt1"/>
+          </a:fontRef>
+        </p:style>
+        <p:txBody>
+          <a:bodyPr rtlCol="0" anchor="ctr"/>
+          <a:lstStyle/>
+          <a:p>
+            <a:pPr algn="ctr"/>
+          </a:p>
+        </p:txBody>
+      </p:sp>
+      <p:sp>
+        <p:nvSpPr>
+          <p:cNvPr id="5" name="TextBox 4"/>
+          <p:cNvSpPr txBox="1"/>
+          <p:nvPr/>
+        </p:nvSpPr>
+        <p:spPr>
+          <a:xfrm>
+            <a:off x="822960" y="621792"/>
+            <a:ext cx="10515600" cy="502920"/>
+          </a:xfrm>
+          <a:prstGeom prst="rect">
+            <a:avLst/>
+          </a:prstGeom>
+          <a:noFill/>
+        </p:spPr>
+        <p:txBody>
+          <a:bodyPr wrap="square">
+            <a:spAutoFit/>
+          </a:bodyPr>
+          <a:lstStyle/>
+          <a:p>
+            <a:pPr algn="l"/>
+            <a:r>
+              <a:rPr sz="2800" b="0" u="none">
+                <a:solidFill>
+                  <a:srgbClr val="1C1914"/>
+                </a:solidFill>
+                <a:latin typeface="Georgia"/>
+              </a:rPr>
+              <a:t>What to open with an AI Engineer</a:t>
+            </a:r>
+          </a:p>
+        </p:txBody>
+      </p:sp>
+      <p:sp>
+        <p:nvSpPr>
+          <p:cNvPr id="6" name="Rectangle 5"/>
+          <p:cNvSpPr/>
+          <p:nvPr/>
+        </p:nvSpPr>
+        <p:spPr>
+          <a:xfrm>
+            <a:off x="502920" y="1325880"/>
+            <a:ext cx="3657600" cy="2148840"/>
+          </a:xfrm>
+          <a:prstGeom prst="rect">
+            <a:avLst/>
+          </a:prstGeom>
+          <a:solidFill>
+            <a:srgbClr val="FFFDF8"/>
+          </a:solidFill>
+          <a:ln w="12700">
+            <a:solidFill>
+              <a:srgbClr val="D9D0C0"/>
+            </a:solidFill>
+          </a:ln>
+        </p:spPr>
+        <p:style>
+          <a:lnRef idx="1">
+            <a:schemeClr val="accent1"/>
+          </a:lnRef>
+          <a:fillRef idx="3">
+            <a:schemeClr val="accent1"/>
+          </a:fillRef>
+          <a:effectRef idx="2">
+            <a:schemeClr val="accent1"/>
+          </a:effectRef>
+          <a:fontRef idx="minor">
+            <a:schemeClr val="lt1"/>
+          </a:fontRef>
+        </p:style>
+        <p:txBody>
+          <a:bodyPr rtlCol="0" anchor="ctr"/>
+          <a:lstStyle/>
+          <a:p>
+            <a:pPr algn="ctr"/>
+          </a:p>
+        </p:txBody>
+      </p:sp>
+      <p:sp>
+        <p:nvSpPr>
+          <p:cNvPr id="7" name="Rectangle 6"/>
+          <p:cNvSpPr/>
+          <p:nvPr/>
+        </p:nvSpPr>
+        <p:spPr>
+          <a:xfrm>
+            <a:off x="502920" y="1325880"/>
+            <a:ext cx="3657600" cy="73152"/>
+          </a:xfrm>
+          <a:prstGeom prst="rect">
+            <a:avLst/>
+          </a:prstGeom>
+          <a:solidFill>
+            <a:srgbClr val="8A6A3B"/>
+          </a:solidFill>
+          <a:ln>
+            <a:noFill/>
+          </a:ln>
+        </p:spPr>
+        <p:style>
+          <a:lnRef idx="1">
+            <a:schemeClr val="accent1"/>
+          </a:lnRef>
+          <a:fillRef idx="3">
+            <a:schemeClr val="accent1"/>
+          </a:fillRef>
+          <a:effectRef idx="2">
+            <a:schemeClr val="accent1"/>
+          </a:effectRef>
+          <a:fontRef idx="minor">
+            <a:schemeClr val="lt1"/>
+          </a:fontRef>
+        </p:style>
+        <p:txBody>
+          <a:bodyPr rtlCol="0" anchor="ctr"/>
+          <a:lstStyle/>
+          <a:p>
+            <a:pPr algn="ctr"/>
+          </a:p>
+        </p:txBody>
+      </p:sp>
+      <p:sp>
+        <p:nvSpPr>
+          <p:cNvPr id="8" name="TextBox 7"/>
+          <p:cNvSpPr txBox="1"/>
+          <p:nvPr/>
+        </p:nvSpPr>
+        <p:spPr>
+          <a:xfrm>
+            <a:off x="685800" y="1554480"/>
+            <a:ext cx="3291840" cy="365760"/>
+          </a:xfrm>
+          <a:prstGeom prst="rect">
+            <a:avLst/>
+          </a:prstGeom>
+          <a:noFill/>
+        </p:spPr>
+        <p:txBody>
+          <a:bodyPr wrap="square">
+            <a:spAutoFit/>
+          </a:bodyPr>
+          <a:lstStyle/>
+          <a:p>
+            <a:pPr algn="l"/>
+            <a:r>
+              <a:rPr sz="1600" b="0" u="none">
+                <a:solidFill>
+                  <a:srgbClr val="1C1914"/>
+                </a:solidFill>
+                <a:latin typeface="Georgia"/>
+              </a:rPr>
+              <a:t>Board brief</a:t>
+            </a:r>
+          </a:p>
+        </p:txBody>
+      </p:sp>
+      <p:sp>
+        <p:nvSpPr>
+          <p:cNvPr id="9" name="TextBox 8"/>
+          <p:cNvSpPr txBox="1"/>
+          <p:nvPr/>
+        </p:nvSpPr>
+        <p:spPr>
+          <a:xfrm>
+            <a:off x="685800" y="2011680"/>
+            <a:ext cx="3291840" cy="1280160"/>
+          </a:xfrm>
+          <a:prstGeom prst="rect">
+            <a:avLst/>
+          </a:prstGeom>
+          <a:noFill/>
+        </p:spPr>
+        <p:txBody>
+          <a:bodyPr wrap="square">
+            <a:spAutoFit/>
+          </a:bodyPr>
+          <a:lstStyle/>
+          <a:p>
+            <a:pPr algn="l"/>
+            <a:r>
+              <a:rPr sz="1300" b="0" u="none">
+                <a:solidFill>
+                  <a:srgbClr val="6B6458"/>
+                </a:solidFill>
+                <a:latin typeface="Calibri"/>
+              </a:rPr>
+              <a:t>Chains share expansion → GM lift → forecast vs run-rate → growth into one spoken narrative.</a:t>
+            </a:r>
+          </a:p>
+        </p:txBody>
+      </p:sp>
+      <p:sp>
+        <p:nvSpPr>
+          <p:cNvPr id="10" name="Rectangle 9"/>
+          <p:cNvSpPr/>
+          <p:nvPr/>
+        </p:nvSpPr>
+        <p:spPr>
+          <a:xfrm>
+            <a:off x="4343400" y="1325880"/>
+            <a:ext cx="3657600" cy="2148840"/>
+          </a:xfrm>
+          <a:prstGeom prst="rect">
+            <a:avLst/>
+          </a:prstGeom>
+          <a:solidFill>
+            <a:srgbClr val="FFFDF8"/>
+          </a:solidFill>
+          <a:ln w="12700">
+            <a:solidFill>
+              <a:srgbClr val="D9D0C0"/>
+            </a:solidFill>
+          </a:ln>
+        </p:spPr>
+        <p:style>
+          <a:lnRef idx="1">
+            <a:schemeClr val="accent1"/>
+          </a:lnRef>
+          <a:fillRef idx="3">
+            <a:schemeClr val="accent1"/>
+          </a:fillRef>
+          <a:effectRef idx="2">
+            <a:schemeClr val="accent1"/>
+          </a:effectRef>
+          <a:fontRef idx="minor">
+            <a:schemeClr val="lt1"/>
+          </a:fontRef>
+        </p:style>
+        <p:txBody>
+          <a:bodyPr rtlCol="0" anchor="ctr"/>
+          <a:lstStyle/>
+          <a:p>
+            <a:pPr algn="ctr"/>
+          </a:p>
+        </p:txBody>
+      </p:sp>
+      <p:sp>
+        <p:nvSpPr>
+          <p:cNvPr id="11" name="Rectangle 10"/>
+          <p:cNvSpPr/>
+          <p:nvPr/>
+        </p:nvSpPr>
+        <p:spPr>
+          <a:xfrm>
+            <a:off x="4343400" y="1325880"/>
+            <a:ext cx="3657600" cy="73152"/>
+          </a:xfrm>
+          <a:prstGeom prst="rect">
+            <a:avLst/>
+          </a:prstGeom>
+          <a:solidFill>
+            <a:srgbClr val="8A6A3B"/>
+          </a:solidFill>
+          <a:ln>
+            <a:noFill/>
+          </a:ln>
+        </p:spPr>
+        <p:style>
+          <a:lnRef idx="1">
+            <a:schemeClr val="accent1"/>
+          </a:lnRef>
+          <a:fillRef idx="3">
+            <a:schemeClr val="accent1"/>
+          </a:fillRef>
+          <a:effectRef idx="2">
+            <a:schemeClr val="accent1"/>
+          </a:effectRef>
+          <a:fontRef idx="minor">
+            <a:schemeClr val="lt1"/>
+          </a:fontRef>
+        </p:style>
+        <p:txBody>
+          <a:bodyPr rtlCol="0" anchor="ctr"/>
+          <a:lstStyle/>
+          <a:p>
+            <a:pPr algn="ctr"/>
+          </a:p>
+        </p:txBody>
+      </p:sp>
+      <p:sp>
+        <p:nvSpPr>
+          <p:cNvPr id="12" name="TextBox 11"/>
+          <p:cNvSpPr txBox="1"/>
+          <p:nvPr/>
+        </p:nvSpPr>
+        <p:spPr>
+          <a:xfrm>
+            <a:off x="4526280" y="1554480"/>
+            <a:ext cx="3291840" cy="365760"/>
+          </a:xfrm>
+          <a:prstGeom prst="rect">
+            <a:avLst/>
+          </a:prstGeom>
+          <a:noFill/>
+        </p:spPr>
+        <p:txBody>
+          <a:bodyPr wrap="square">
+            <a:spAutoFit/>
+          </a:bodyPr>
+          <a:lstStyle/>
+          <a:p>
+            <a:pPr algn="l"/>
+            <a:r>
+              <a:rPr sz="1600" b="0" u="none">
+                <a:solidFill>
+                  <a:srgbClr val="1C1914"/>
+                </a:solidFill>
+                <a:latin typeface="Georgia"/>
+              </a:rPr>
+              <a:t>Eval harness</a:t>
+            </a:r>
+          </a:p>
+        </p:txBody>
+      </p:sp>
+      <p:sp>
+        <p:nvSpPr>
+          <p:cNvPr id="13" name="TextBox 12"/>
+          <p:cNvSpPr txBox="1"/>
+          <p:nvPr/>
+        </p:nvSpPr>
+        <p:spPr>
+          <a:xfrm>
+            <a:off x="4526280" y="2011680"/>
+            <a:ext cx="3291840" cy="1280160"/>
+          </a:xfrm>
+          <a:prstGeom prst="rect">
+            <a:avLst/>
+          </a:prstGeom>
+          <a:noFill/>
+        </p:spPr>
+        <p:txBody>
+          <a:bodyPr wrap="square">
+            <a:spAutoFit/>
+          </a:bodyPr>
+          <a:lstStyle/>
+          <a:p>
+            <a:pPr algn="l"/>
+            <a:r>
+              <a:rPr sz="1300" b="0" u="none">
+                <a:solidFill>
+                  <a:srgbClr val="6B6458"/>
+                </a:solidFill>
+                <a:latin typeface="Calibri"/>
+              </a:rPr>
+              <a:t>20 golden prompts: FAQ · metric · voice fuzzy · refuse. Pass/fail + latency on screen.</a:t>
+            </a:r>
+          </a:p>
+        </p:txBody>
+      </p:sp>
+      <p:sp>
+        <p:nvSpPr>
+          <p:cNvPr id="14" name="Rectangle 13"/>
+          <p:cNvSpPr/>
+          <p:nvPr/>
+        </p:nvSpPr>
+        <p:spPr>
+          <a:xfrm>
+            <a:off x="8183880" y="1325880"/>
+            <a:ext cx="3657600" cy="2148840"/>
+          </a:xfrm>
+          <a:prstGeom prst="rect">
+            <a:avLst/>
+          </a:prstGeom>
+          <a:solidFill>
+            <a:srgbClr val="FFFDF8"/>
+          </a:solidFill>
+          <a:ln w="12700">
+            <a:solidFill>
+              <a:srgbClr val="D9D0C0"/>
+            </a:solidFill>
+          </a:ln>
+        </p:spPr>
+        <p:style>
+          <a:lnRef idx="1">
+            <a:schemeClr val="accent1"/>
+          </a:lnRef>
+          <a:fillRef idx="3">
+            <a:schemeClr val="accent1"/>
+          </a:fillRef>
+          <a:effectRef idx="2">
+            <a:schemeClr val="accent1"/>
+          </a:effectRef>
+          <a:fontRef idx="minor">
+            <a:schemeClr val="lt1"/>
+          </a:fontRef>
+        </p:style>
+        <p:txBody>
+          <a:bodyPr rtlCol="0" anchor="ctr"/>
+          <a:lstStyle/>
+          <a:p>
+            <a:pPr algn="ctr"/>
+          </a:p>
+        </p:txBody>
+      </p:sp>
+      <p:sp>
+        <p:nvSpPr>
+          <p:cNvPr id="15" name="Rectangle 14"/>
+          <p:cNvSpPr/>
+          <p:nvPr/>
+        </p:nvSpPr>
+        <p:spPr>
+          <a:xfrm>
+            <a:off x="8183880" y="1325880"/>
+            <a:ext cx="3657600" cy="73152"/>
+          </a:xfrm>
+          <a:prstGeom prst="rect">
+            <a:avLst/>
+          </a:prstGeom>
+          <a:solidFill>
+            <a:srgbClr val="8A6A3B"/>
+          </a:solidFill>
+          <a:ln>
+            <a:noFill/>
+          </a:ln>
+        </p:spPr>
+        <p:style>
+          <a:lnRef idx="1">
+            <a:schemeClr val="accent1"/>
+          </a:lnRef>
+          <a:fillRef idx="3">
+            <a:schemeClr val="accent1"/>
+          </a:fillRef>
+          <a:effectRef idx="2">
+            <a:schemeClr val="accent1"/>
+          </a:effectRef>
+          <a:fontRef idx="minor">
+            <a:schemeClr val="lt1"/>
+          </a:fontRef>
+        </p:style>
+        <p:txBody>
+          <a:bodyPr rtlCol="0" anchor="ctr"/>
+          <a:lstStyle/>
+          <a:p>
+            <a:pPr algn="ctr"/>
+          </a:p>
+        </p:txBody>
+      </p:sp>
+      <p:sp>
+        <p:nvSpPr>
+          <p:cNvPr id="16" name="TextBox 15"/>
+          <p:cNvSpPr txBox="1"/>
+          <p:nvPr/>
+        </p:nvSpPr>
+        <p:spPr>
+          <a:xfrm>
+            <a:off x="8366760" y="1554480"/>
+            <a:ext cx="3291840" cy="365760"/>
+          </a:xfrm>
+          <a:prstGeom prst="rect">
+            <a:avLst/>
+          </a:prstGeom>
+          <a:noFill/>
+        </p:spPr>
+        <p:txBody>
+          <a:bodyPr wrap="square">
+            <a:spAutoFit/>
+          </a:bodyPr>
+          <a:lstStyle/>
+          <a:p>
+            <a:pPr algn="l"/>
+            <a:r>
+              <a:rPr sz="1600" b="0" u="none">
+                <a:solidFill>
+                  <a:srgbClr val="1C1914"/>
+                </a:solidFill>
+                <a:latin typeface="Georgia"/>
+              </a:rPr>
+              <a:t>Cortex vs governed</a:t>
+            </a:r>
+          </a:p>
+        </p:txBody>
+      </p:sp>
+      <p:sp>
+        <p:nvSpPr>
+          <p:cNvPr id="17" name="TextBox 16"/>
+          <p:cNvSpPr txBox="1"/>
+          <p:nvPr/>
+        </p:nvSpPr>
+        <p:spPr>
+          <a:xfrm>
+            <a:off x="8366760" y="2011680"/>
+            <a:ext cx="3291840" cy="1280160"/>
+          </a:xfrm>
+          <a:prstGeom prst="rect">
+            <a:avLst/>
+          </a:prstGeom>
+          <a:noFill/>
+        </p:spPr>
+        <p:txBody>
+          <a:bodyPr wrap="square">
+            <a:spAutoFit/>
+          </a:bodyPr>
+          <a:lstStyle/>
+          <a:p>
+            <a:pPr algn="l"/>
+            <a:r>
+              <a:rPr sz="1300" b="0" u="none">
+                <a:solidFill>
+                  <a:srgbClr val="6B6458"/>
+                </a:solidFill>
+                <a:latin typeface="Calibri"/>
+              </a:rPr>
+              <a:t>Same question side-by-side. Prefer closed metrics; Cortex is discovery/fallback.</a:t>
+            </a:r>
+          </a:p>
+        </p:txBody>
+      </p:sp>
+      <p:sp>
+        <p:nvSpPr>
+          <p:cNvPr id="18" name="Rectangle 17"/>
+          <p:cNvSpPr/>
+          <p:nvPr/>
+        </p:nvSpPr>
+        <p:spPr>
+          <a:xfrm>
+            <a:off x="502920" y="3657600"/>
+            <a:ext cx="3657600" cy="2148840"/>
+          </a:xfrm>
+          <a:prstGeom prst="rect">
+            <a:avLst/>
+          </a:prstGeom>
+          <a:solidFill>
+            <a:srgbClr val="FFFDF8"/>
+          </a:solidFill>
+          <a:ln w="12700">
+            <a:solidFill>
+              <a:srgbClr val="D9D0C0"/>
+            </a:solidFill>
+          </a:ln>
+        </p:spPr>
+        <p:style>
+          <a:lnRef idx="1">
+            <a:schemeClr val="accent1"/>
+          </a:lnRef>
+          <a:fillRef idx="3">
+            <a:schemeClr val="accent1"/>
+          </a:fillRef>
+          <a:effectRef idx="2">
+            <a:schemeClr val="accent1"/>
+          </a:effectRef>
+          <a:fontRef idx="minor">
+            <a:schemeClr val="lt1"/>
+          </a:fontRef>
+        </p:style>
+        <p:txBody>
+          <a:bodyPr rtlCol="0" anchor="ctr"/>
+          <a:lstStyle/>
+          <a:p>
+            <a:pPr algn="ctr"/>
+          </a:p>
+        </p:txBody>
+      </p:sp>
+      <p:sp>
+        <p:nvSpPr>
+          <p:cNvPr id="19" name="Rectangle 18"/>
+          <p:cNvSpPr/>
+          <p:nvPr/>
+        </p:nvSpPr>
+        <p:spPr>
+          <a:xfrm>
+            <a:off x="502920" y="3657600"/>
+            <a:ext cx="3657600" cy="73152"/>
+          </a:xfrm>
+          <a:prstGeom prst="rect">
+            <a:avLst/>
+          </a:prstGeom>
+          <a:solidFill>
+            <a:srgbClr val="8A6A3B"/>
+          </a:solidFill>
+          <a:ln>
+            <a:noFill/>
+          </a:ln>
+        </p:spPr>
+        <p:style>
+          <a:lnRef idx="1">
+            <a:schemeClr val="accent1"/>
+          </a:lnRef>
+          <a:fillRef idx="3">
+            <a:schemeClr val="accent1"/>
+          </a:fillRef>
+          <a:effectRef idx="2">
+            <a:schemeClr val="accent1"/>
+          </a:effectRef>
+          <a:fontRef idx="minor">
+            <a:schemeClr val="lt1"/>
+          </a:fontRef>
+        </p:style>
+        <p:txBody>
+          <a:bodyPr rtlCol="0" anchor="ctr"/>
+          <a:lstStyle/>
+          <a:p>
+            <a:pPr algn="ctr"/>
+          </a:p>
+        </p:txBody>
+      </p:sp>
+      <p:sp>
+        <p:nvSpPr>
+          <p:cNvPr id="20" name="TextBox 19"/>
+          <p:cNvSpPr txBox="1"/>
+          <p:nvPr/>
+        </p:nvSpPr>
+        <p:spPr>
+          <a:xfrm>
+            <a:off x="685800" y="3886200"/>
+            <a:ext cx="3291840" cy="365760"/>
+          </a:xfrm>
+          <a:prstGeom prst="rect">
+            <a:avLst/>
+          </a:prstGeom>
+          <a:noFill/>
+        </p:spPr>
+        <p:txBody>
+          <a:bodyPr wrap="square">
+            <a:spAutoFit/>
+          </a:bodyPr>
+          <a:lstStyle/>
+          <a:p>
+            <a:pPr algn="l"/>
+            <a:r>
+              <a:rPr sz="1600" b="0" u="none">
+                <a:solidFill>
+                  <a:srgbClr val="1C1914"/>
+                </a:solidFill>
+                <a:latin typeface="Georgia"/>
+              </a:rPr>
+              <a:t>Scope / RAP story</a:t>
+            </a:r>
+          </a:p>
+        </p:txBody>
+      </p:sp>
+      <p:sp>
+        <p:nvSpPr>
+          <p:cNvPr id="21" name="TextBox 20"/>
+          <p:cNvSpPr txBox="1"/>
+          <p:nvPr/>
+        </p:nvSpPr>
+        <p:spPr>
+          <a:xfrm>
+            <a:off x="685800" y="4343400"/>
+            <a:ext cx="3291840" cy="1280160"/>
+          </a:xfrm>
+          <a:prstGeom prst="rect">
+            <a:avLst/>
+          </a:prstGeom>
+          <a:noFill/>
+        </p:spPr>
+        <p:txBody>
+          <a:bodyPr wrap="square">
+            <a:spAutoFit/>
+          </a:bodyPr>
+          <a:lstStyle/>
+          <a:p>
+            <a:pPr algn="l"/>
+            <a:r>
+              <a:rPr sz="1300" b="0" u="none">
+                <a:solidFill>
+                  <a:srgbClr val="6B6458"/>
+                </a:solidFill>
+                <a:latin typeface="Calibri"/>
+              </a:rPr>
+              <a:t>Operator pins DLR-0001 — same ask, fewer rows. App-layer mirror of Snowflake RAP.</a:t>
+            </a:r>
+          </a:p>
+        </p:txBody>
+      </p:sp>
+      <p:sp>
+        <p:nvSpPr>
+          <p:cNvPr id="22" name="Rectangle 21"/>
+          <p:cNvSpPr/>
+          <p:nvPr/>
+        </p:nvSpPr>
+        <p:spPr>
+          <a:xfrm>
+            <a:off x="4343400" y="3657600"/>
+            <a:ext cx="3657600" cy="2148840"/>
+          </a:xfrm>
+          <a:prstGeom prst="rect">
+            <a:avLst/>
+          </a:prstGeom>
+          <a:solidFill>
+            <a:srgbClr val="FFFDF8"/>
+          </a:solidFill>
+          <a:ln w="12700">
+            <a:solidFill>
+              <a:srgbClr val="D9D0C0"/>
+            </a:solidFill>
+          </a:ln>
+        </p:spPr>
+        <p:style>
+          <a:lnRef idx="1">
+            <a:schemeClr val="accent1"/>
+          </a:lnRef>
+          <a:fillRef idx="3">
+            <a:schemeClr val="accent1"/>
+          </a:fillRef>
+          <a:effectRef idx="2">
+            <a:schemeClr val="accent1"/>
+          </a:effectRef>
+          <a:fontRef idx="minor">
+            <a:schemeClr val="lt1"/>
+          </a:fontRef>
+        </p:style>
+        <p:txBody>
+          <a:bodyPr rtlCol="0" anchor="ctr"/>
+          <a:lstStyle/>
+          <a:p>
+            <a:pPr algn="ctr"/>
+          </a:p>
+        </p:txBody>
+      </p:sp>
+      <p:sp>
+        <p:nvSpPr>
+          <p:cNvPr id="23" name="Rectangle 22"/>
+          <p:cNvSpPr/>
+          <p:nvPr/>
+        </p:nvSpPr>
+        <p:spPr>
+          <a:xfrm>
+            <a:off x="4343400" y="3657600"/>
+            <a:ext cx="3657600" cy="73152"/>
+          </a:xfrm>
+          <a:prstGeom prst="rect">
+            <a:avLst/>
+          </a:prstGeom>
+          <a:solidFill>
+            <a:srgbClr val="8A6A3B"/>
+          </a:solidFill>
+          <a:ln>
+            <a:noFill/>
+          </a:ln>
+        </p:spPr>
+        <p:style>
+          <a:lnRef idx="1">
+            <a:schemeClr val="accent1"/>
+          </a:lnRef>
+          <a:fillRef idx="3">
+            <a:schemeClr val="accent1"/>
+          </a:fillRef>
+          <a:effectRef idx="2">
+            <a:schemeClr val="accent1"/>
+          </a:effectRef>
+          <a:fontRef idx="minor">
+            <a:schemeClr val="lt1"/>
+          </a:fontRef>
+        </p:style>
+        <p:txBody>
+          <a:bodyPr rtlCol="0" anchor="ctr"/>
+          <a:lstStyle/>
+          <a:p>
+            <a:pPr algn="ctr"/>
+          </a:p>
+        </p:txBody>
+      </p:sp>
+      <p:sp>
+        <p:nvSpPr>
+          <p:cNvPr id="24" name="TextBox 23"/>
+          <p:cNvSpPr txBox="1"/>
+          <p:nvPr/>
+        </p:nvSpPr>
+        <p:spPr>
+          <a:xfrm>
+            <a:off x="4526280" y="3886200"/>
+            <a:ext cx="3291840" cy="365760"/>
+          </a:xfrm>
+          <a:prstGeom prst="rect">
+            <a:avLst/>
+          </a:prstGeom>
+          <a:noFill/>
+        </p:spPr>
+        <p:txBody>
+          <a:bodyPr wrap="square">
+            <a:spAutoFit/>
+          </a:bodyPr>
+          <a:lstStyle/>
+          <a:p>
+            <a:pPr algn="l"/>
+            <a:r>
+              <a:rPr sz="1600" b="0" u="none">
+                <a:solidFill>
+                  <a:srgbClr val="1C1914"/>
+                </a:solidFill>
+                <a:latin typeface="Georgia"/>
+              </a:rPr>
+              <a:t>90-day plan</a:t>
+            </a:r>
+          </a:p>
+        </p:txBody>
+      </p:sp>
+      <p:sp>
+        <p:nvSpPr>
+          <p:cNvPr id="25" name="TextBox 24"/>
+          <p:cNvSpPr txBox="1"/>
+          <p:nvPr/>
+        </p:nvSpPr>
+        <p:spPr>
+          <a:xfrm>
+            <a:off x="4526280" y="4343400"/>
+            <a:ext cx="3291840" cy="1280160"/>
+          </a:xfrm>
+          <a:prstGeom prst="rect">
+            <a:avLst/>
+          </a:prstGeom>
+          <a:noFill/>
+        </p:spPr>
+        <p:txBody>
+          <a:bodyPr wrap="square">
+            <a:spAutoFit/>
+          </a:bodyPr>
+          <a:lstStyle/>
+          <a:p>
+            <a:pPr algn="l"/>
+            <a:r>
+              <a:rPr sz="1300" b="0" u="none">
+                <a:solidFill>
+                  <a:srgbClr val="6B6458"/>
+                </a:solidFill>
+                <a:latin typeface="Calibri"/>
+              </a:rPr>
+              <a:t>Grounding → measure → harden. Non-goals: no invented order status, no day-one phone replacement.</a:t>
+            </a:r>
+          </a:p>
+        </p:txBody>
+      </p:sp>
+      <p:sp>
+        <p:nvSpPr>
+          <p:cNvPr id="26" name="Rectangle 25"/>
+          <p:cNvSpPr/>
+          <p:nvPr/>
+        </p:nvSpPr>
+        <p:spPr>
+          <a:xfrm>
+            <a:off x="8183880" y="3657600"/>
+            <a:ext cx="3657600" cy="2148840"/>
+          </a:xfrm>
+          <a:prstGeom prst="rect">
+            <a:avLst/>
+          </a:prstGeom>
+          <a:solidFill>
+            <a:srgbClr val="FFFDF8"/>
+          </a:solidFill>
+          <a:ln w="12700">
+            <a:solidFill>
+              <a:srgbClr val="D9D0C0"/>
+            </a:solidFill>
+          </a:ln>
+        </p:spPr>
+        <p:style>
+          <a:lnRef idx="1">
+            <a:schemeClr val="accent1"/>
+          </a:lnRef>
+          <a:fillRef idx="3">
+            <a:schemeClr val="accent1"/>
+          </a:fillRef>
+          <a:effectRef idx="2">
+            <a:schemeClr val="accent1"/>
+          </a:effectRef>
+          <a:fontRef idx="minor">
+            <a:schemeClr val="lt1"/>
+          </a:fontRef>
+        </p:style>
+        <p:txBody>
+          <a:bodyPr rtlCol="0" anchor="ctr"/>
+          <a:lstStyle/>
+          <a:p>
+            <a:pPr algn="ctr"/>
+          </a:p>
+        </p:txBody>
+      </p:sp>
+      <p:sp>
+        <p:nvSpPr>
+          <p:cNvPr id="27" name="Rectangle 26"/>
+          <p:cNvSpPr/>
+          <p:nvPr/>
+        </p:nvSpPr>
+        <p:spPr>
+          <a:xfrm>
+            <a:off x="8183880" y="3657600"/>
+            <a:ext cx="3657600" cy="73152"/>
+          </a:xfrm>
+          <a:prstGeom prst="rect">
+            <a:avLst/>
+          </a:prstGeom>
+          <a:solidFill>
+            <a:srgbClr val="8A6A3B"/>
+          </a:solidFill>
+          <a:ln>
+            <a:noFill/>
+          </a:ln>
+        </p:spPr>
+        <p:style>
+          <a:lnRef idx="1">
+            <a:schemeClr val="accent1"/>
+          </a:lnRef>
+          <a:fillRef idx="3">
+            <a:schemeClr val="accent1"/>
+          </a:fillRef>
+          <a:effectRef idx="2">
+            <a:schemeClr val="accent1"/>
+          </a:effectRef>
+          <a:fontRef idx="minor">
+            <a:schemeClr val="lt1"/>
+          </a:fontRef>
+        </p:style>
+        <p:txBody>
+          <a:bodyPr rtlCol="0" anchor="ctr"/>
+          <a:lstStyle/>
+          <a:p>
+            <a:pPr algn="ctr"/>
+          </a:p>
+        </p:txBody>
+      </p:sp>
+      <p:sp>
+        <p:nvSpPr>
+          <p:cNvPr id="28" name="TextBox 27"/>
+          <p:cNvSpPr txBox="1"/>
+          <p:nvPr/>
+        </p:nvSpPr>
+        <p:spPr>
+          <a:xfrm>
+            <a:off x="8366760" y="3886200"/>
+            <a:ext cx="3291840" cy="365760"/>
+          </a:xfrm>
+          <a:prstGeom prst="rect">
+            <a:avLst/>
+          </a:prstGeom>
+          <a:noFill/>
+        </p:spPr>
+        <p:txBody>
+          <a:bodyPr wrap="square">
+            <a:spAutoFit/>
+          </a:bodyPr>
+          <a:lstStyle/>
+          <a:p>
+            <a:pPr algn="l"/>
+            <a:r>
+              <a:rPr sz="1600" b="0" u="none">
+                <a:solidFill>
+                  <a:srgbClr val="1C1914"/>
+                </a:solidFill>
+                <a:latin typeface="Georgia"/>
+              </a:rPr>
+              <a:t>Market + voice</a:t>
+            </a:r>
+          </a:p>
+        </p:txBody>
+      </p:sp>
+      <p:sp>
+        <p:nvSpPr>
+          <p:cNvPr id="29" name="TextBox 28"/>
+          <p:cNvSpPr txBox="1"/>
+          <p:nvPr/>
+        </p:nvSpPr>
+        <p:spPr>
+          <a:xfrm>
+            <a:off x="8366760" y="4343400"/>
+            <a:ext cx="3291840" cy="1280160"/>
+          </a:xfrm>
+          <a:prstGeom prst="rect">
+            <a:avLst/>
+          </a:prstGeom>
+          <a:noFill/>
+        </p:spPr>
+        <p:txBody>
+          <a:bodyPr wrap="square">
+            <a:spAutoFit/>
+          </a:bodyPr>
+          <a:lstStyle/>
+          <a:p>
+            <a:pPr algn="l"/>
+            <a:r>
+              <a:rPr sz="1300" b="0" u="none">
+                <a:solidFill>
+                  <a:srgbClr val="6B6458"/>
+                </a:solidFill>
+                <a:latin typeface="Calibri"/>
+              </a:rPr>
+              <a:t>Competitor landscape (public-estimate), continuous Mic on Snowflake, Market analytics tab.</a:t>
+            </a:r>
+          </a:p>
+        </p:txBody>
+      </p:sp>
+      <p:sp>
+        <p:nvSpPr>
+          <p:cNvPr id="30" name="TextBox 29"/>
+          <p:cNvSpPr txBox="1"/>
+          <p:nvPr/>
+        </p:nvSpPr>
+        <p:spPr>
+          <a:xfrm>
+            <a:off x="457200" y="6510528"/>
+            <a:ext cx="5943600" cy="256032"/>
+          </a:xfrm>
+          <a:prstGeom prst="rect">
+            <a:avLst/>
+          </a:prstGeom>
+          <a:noFill/>
+        </p:spPr>
+        <p:txBody>
+          <a:bodyPr wrap="square">
+            <a:spAutoFit/>
+          </a:bodyPr>
+          <a:lstStyle/>
+          <a:p>
+            <a:pPr algn="l"/>
+            <a:r>
+              <a:rPr sz="1000" b="0" u="none">
+                <a:solidFill>
+                  <a:srgbClr val="6B6458"/>
+                </a:solidFill>
+                <a:latin typeface="Calibri"/>
+              </a:rPr>
+              <a:t>VC Retail Analytics  ·  synthetic</a:t>
+            </a:r>
+          </a:p>
+        </p:txBody>
+      </p:sp>
+      <p:sp>
+        <p:nvSpPr>
+          <p:cNvPr id="31" name="Rectangle 30">
+            <a:hlinkClick r:id="rId2"/>
+          </p:cNvPr>
+          <p:cNvSpPr/>
+          <p:nvPr/>
+        </p:nvSpPr>
+        <p:spPr>
+          <a:xfrm>
+            <a:off x="6583680" y="6446520"/>
+            <a:ext cx="3931920" cy="292608"/>
+          </a:xfrm>
+          <a:prstGeom prst="rect">
+            <a:avLst/>
+          </a:prstGeom>
+          <a:solidFill>
+            <a:srgbClr val="E8DFCF"/>
+          </a:solidFill>
+          <a:ln>
+            <a:noFill/>
+          </a:ln>
+        </p:spPr>
+        <p:style>
+          <a:lnRef idx="1">
+            <a:schemeClr val="accent1"/>
+          </a:lnRef>
+          <a:fillRef idx="3">
+            <a:schemeClr val="accent1"/>
+          </a:fillRef>
+          <a:effectRef idx="2">
+            <a:schemeClr val="accent1"/>
+          </a:effectRef>
+          <a:fontRef idx="minor">
+            <a:schemeClr val="lt1"/>
+          </a:fontRef>
+        </p:style>
+        <p:txBody>
+          <a:bodyPr rtlCol="0" anchor="ctr" wrap="square"/>
+          <a:lstStyle/>
+          <a:p>
+            <a:pPr algn="ctr"/>
+            <a:r>
+              <a:rPr sz="1000" b="1" u="none">
+                <a:solidFill>
+                  <a:srgbClr val="8A6A3B"/>
+                </a:solidFill>
+                <a:latin typeface="Calibri"/>
+                <a:hlinkClick r:id="rId2"/>
+              </a:rPr>
+              <a:t>https://vc.datasharkbi.com</a:t>
+            </a:r>
+          </a:p>
+        </p:txBody>
+      </p:sp>
+      <p:sp>
+        <p:nvSpPr>
+          <p:cNvPr id="32" name="TextBox 31"/>
+          <p:cNvSpPr txBox="1"/>
+          <p:nvPr/>
+        </p:nvSpPr>
+        <p:spPr>
+          <a:xfrm>
+            <a:off x="10698480" y="6510528"/>
+            <a:ext cx="1097280" cy="256032"/>
+          </a:xfrm>
+          <a:prstGeom prst="rect">
+            <a:avLst/>
+          </a:prstGeom>
+          <a:noFill/>
+        </p:spPr>
+        <p:txBody>
+          <a:bodyPr wrap="square">
+            <a:spAutoFit/>
+          </a:bodyPr>
+          <a:lstStyle/>
+          <a:p>
+            <a:pPr algn="r"/>
+            <a:r>
+              <a:rPr sz="1000" b="0" u="none">
+                <a:solidFill>
+                  <a:srgbClr val="6B6458"/>
+                </a:solidFill>
+                <a:latin typeface="Calibri"/>
+              </a:rPr>
+              <a:t>17/18</a:t>
+            </a:r>
+          </a:p>
+        </p:txBody>
+      </p:sp>
+    </p:spTree>
+  </p:cSld>
+  <p:clrMapOvr>
+    <a:masterClrMapping/>
+  </p:clrMapOvr>
+</p:sld>
+</file>
+
+<file path=ppt/slides/slide18.xml><?xml version="1.0" encoding="utf-8"?>
+<p:sld xmlns:a="http://schemas.openxmlformats.org/drawingml/2006/main" xmlns:p="http://schemas.openxmlformats.org/presentationml/2006/main" xmlns:r="http://schemas.openxmlformats.org/officeDocument/2006/relationships">
+  <p:cSld>
+    <p:spTree>
+      <p:nvGrpSpPr>
+        <p:cNvPr id="1" name=""/>
+        <p:cNvGrpSpPr/>
+        <p:nvPr/>
+      </p:nvGrpSpPr>
+      <p:grpSpPr/>
+      <p:sp>
+        <p:nvSpPr>
+          <p:cNvPr id="2" name="Rectangle 1"/>
+          <p:cNvSpPr/>
+          <p:nvPr/>
+        </p:nvSpPr>
+        <p:spPr>
+          <a:xfrm>
+            <a:off x="0" y="0"/>
+            <a:ext cx="12191695" cy="6858000"/>
+          </a:xfrm>
+          <a:prstGeom prst="rect">
+            <a:avLst/>
+          </a:prstGeom>
+          <a:solidFill>
             <a:srgbClr val="1C1914"/>
           </a:solidFill>
           <a:ln>
@@ -7427,7 +8675,7 @@
                 </a:solidFill>
                 <a:latin typeface="Calibri"/>
               </a:rPr>
-              <a:t>dlr-0001 / vc-demo
+              <a:t>operator / vc-demo
 Not Visual Comfort production data.</a:t>
             </a:r>
           </a:p>
@@ -8149,7 +9397,7 @@
                 </a:solidFill>
                 <a:latin typeface="Calibri"/>
               </a:rPr>
-              <a:t>dlr-0001 / vc-demo</a:t>
+              <a:t>operator / vc-demo</a:t>
             </a:r>
           </a:p>
         </p:txBody>
@@ -8535,7 +9783,7 @@
                 </a:solidFill>
                 <a:latin typeface="Calibri"/>
               </a:rPr>
-              <a:t>Overview → Analytics → Assistant → Catalog</a:t>
+              <a:t>Overview → Analytics (Market) → Lab → Assistant</a:t>
             </a:r>
           </a:p>
         </p:txBody>
@@ -8660,7 +9908,7 @@
                 </a:solidFill>
                 <a:latin typeface="Calibri"/>
               </a:rPr>
-              <a:t>2/17</a:t>
+              <a:t>2/18</a:t>
             </a:r>
           </a:p>
         </p:txBody>
@@ -9363,7 +10611,7 @@
                 </a:solidFill>
                 <a:latin typeface="Calibri"/>
               </a:rPr>
-              <a:t>3/17</a:t>
+              <a:t>3/18</a:t>
             </a:r>
           </a:p>
         </p:txBody>
@@ -9686,7 +10934,7 @@
                 </a:solidFill>
                 <a:latin typeface="Calibri"/>
               </a:rPr>
-              <a:t>4/17</a:t>
+              <a:t>4/18</a:t>
             </a:r>
           </a:p>
         </p:txBody>
@@ -10429,7 +11677,7 @@
                 </a:solidFill>
                 <a:latin typeface="Calibri"/>
               </a:rPr>
-              <a:t>5/17</a:t>
+              <a:t>5/18</a:t>
             </a:r>
           </a:p>
         </p:txBody>
@@ -10752,7 +12000,7 @@
                 </a:solidFill>
                 <a:latin typeface="Calibri"/>
               </a:rPr>
-              <a:t>6/17</a:t>
+              <a:t>6/18</a:t>
             </a:r>
           </a:p>
         </p:txBody>
@@ -11955,7 +13203,7 @@
                 </a:solidFill>
                 <a:latin typeface="Calibri"/>
               </a:rPr>
-              <a:t>7/17</a:t>
+              <a:t>7/18</a:t>
             </a:r>
           </a:p>
         </p:txBody>
@@ -12856,7 +14104,7 @@
                 </a:solidFill>
                 <a:latin typeface="Calibri"/>
               </a:rPr>
-              <a:t>8/17</a:t>
+              <a:t>8/18</a:t>
             </a:r>
           </a:p>
         </p:txBody>
@@ -13519,7 +14767,7 @@
                 </a:solidFill>
                 <a:latin typeface="Calibri"/>
               </a:rPr>
-              <a:t>9/17</a:t>
+              <a:t>9/18</a:t>
             </a:r>
           </a:p>
         </p:txBody>

</xml_diff>